<commit_message>
feat(v1): deterministic LLM options + native-RTOS truth-sync across README/report/deck
</commit_message>
<xml_diff>
--- a/docs/final review/KINETIQ_V1_final_review.pptx
+++ b/docs/final review/KINETIQ_V1_final_review.pptx
@@ -6890,13 +6890,7 @@
               </a:spcAft>
             </a:pPr>
             <a:r>
-              <a:rPr sz="1300" b="0" i="0">
-                <a:solidFill>
-                  <a:srgbClr val="262626"/>
-                </a:solidFill>
-                <a:latin typeface="Times New Roman"/>
-              </a:rPr>
-              <a:t>Honest status: v1 software complete · hardware designed and ordered · Wokwi simulation next week; HR/SpO2 via wearable bridge is a timeboxed stretch goal.</a:t>
+              <a:t>Honest status: Wokwi browser sim + native FreeRTOS node (keyboard-driven) ✓ · physical units next week; HR/SpO2 via wearable bridge is a timeboxed stretch goal.</a:t>
             </a:r>
           </a:p>
         </p:txBody>

</xml_diff>